<commit_message>
Backup automatico dom 14/06/2026 23:19:16.68
</commit_message>
<xml_diff>
--- a/[SPSA] Ausentismo y Rotación.pptx
+++ b/[SPSA] Ausentismo y Rotación.pptx
@@ -11803,10 +11803,10 @@
 </file>
 
 <file path=customXml/item1.xml><?xml version="1.0" encoding="utf-8"?>
-<ct:contentTypeSchema xmlns:ct="http://schemas.microsoft.com/office/2006/metadata/contentType" xmlns:ma="http://schemas.microsoft.com/office/2006/metadata/properties/metaAttributes" ct:_="" ma:_="" ma:contentTypeName="Documento" ma:contentTypeID="0x010100D8D2C543C0B9034FB85376E56149363B" ma:contentTypeVersion="20" ma:contentTypeDescription="Crear nuevo documento." ma:contentTypeScope="" ma:versionID="52e7dc5e1594a71ae7d84e8a52896fbf">
-  <xsd:schema xmlns:xsd="http://www.w3.org/2001/XMLSchema" xmlns:xs="http://www.w3.org/2001/XMLSchema" xmlns:p="http://schemas.microsoft.com/office/2006/metadata/properties" xmlns:ns2="80552416-44e0-4a04-af47-76b16d2fbd4a" xmlns:ns3="0b545d44-96d5-42ca-b29a-703cc1f24668" targetNamespace="http://schemas.microsoft.com/office/2006/metadata/properties" ma:root="true" ma:fieldsID="1a601c0bb66d7cf6395162bed6a0ad3c" ns2:_="" ns3:_="">
-    <xsd:import namespace="80552416-44e0-4a04-af47-76b16d2fbd4a"/>
-    <xsd:import namespace="0b545d44-96d5-42ca-b29a-703cc1f24668"/>
+<ct:contentTypeSchema xmlns:ct="http://schemas.microsoft.com/office/2006/metadata/contentType" xmlns:ma="http://schemas.microsoft.com/office/2006/metadata/properties/metaAttributes" ct:_="" ma:_="" ma:contentTypeName="Documento" ma:contentTypeID="0x01010018451F55413CCE40B32872F2EE2F7B17" ma:contentTypeVersion="14" ma:contentTypeDescription="Crear nuevo documento." ma:contentTypeScope="" ma:versionID="969693e52f69943e32048b02ca88382a">
+  <xsd:schema xmlns:xsd="http://www.w3.org/2001/XMLSchema" xmlns:xs="http://www.w3.org/2001/XMLSchema" xmlns:p="http://schemas.microsoft.com/office/2006/metadata/properties" xmlns:ns2="8574a8e8-5383-43f9-82c2-17454492c82a" xmlns:ns3="d25c0998-d329-4608-bd73-3e8a880c0119" targetNamespace="http://schemas.microsoft.com/office/2006/metadata/properties" ma:root="true" ma:fieldsID="069909415eb877d2dc8b3adebaeaef02" ns2:_="" ns3:_="">
+    <xsd:import namespace="8574a8e8-5383-43f9-82c2-17454492c82a"/>
+    <xsd:import namespace="d25c0998-d329-4608-bd73-3e8a880c0119"/>
     <xsd:element name="properties">
       <xsd:complexType>
         <xsd:sequence>
@@ -11815,17 +11815,17 @@
               <xsd:all>
                 <xsd:element ref="ns2:MediaServiceMetadata" minOccurs="0"/>
                 <xsd:element ref="ns2:MediaServiceFastMetadata" minOccurs="0"/>
-                <xsd:element ref="ns2:MediaServiceSearchProperties" minOccurs="0"/>
-                <xsd:element ref="ns2:MediaServiceObjectDetectorVersions" minOccurs="0"/>
-                <xsd:element ref="ns2:MediaServiceDateTaken" minOccurs="0"/>
+                <xsd:element ref="ns2:lcf76f155ced4ddcb4097134ff3c332f" minOccurs="0"/>
+                <xsd:element ref="ns3:TaxCatchAll" minOccurs="0"/>
+                <xsd:element ref="ns2:MediaServiceOCR" minOccurs="0"/>
                 <xsd:element ref="ns2:MediaServiceGenerationTime" minOccurs="0"/>
                 <xsd:element ref="ns2:MediaServiceEventHashCode" minOccurs="0"/>
+                <xsd:element ref="ns2:MediaServiceObjectDetectorVersions" minOccurs="0"/>
                 <xsd:element ref="ns2:MediaLengthInSeconds" minOccurs="0"/>
-                <xsd:element ref="ns3:TaxCatchAll" minOccurs="0"/>
-                <xsd:element ref="ns2:MediaServiceOCR" minOccurs="0"/>
-                <xsd:element ref="ns2:lcf76f155ced4ddcb4097134ff3c332f" minOccurs="0"/>
-                <xsd:element ref="ns2:MediaServiceLocation" minOccurs="0"/>
-                <xsd:element ref="ns2:MediaServiceBillingMetadata" minOccurs="0"/>
+                <xsd:element ref="ns2:MediaServiceDateTaken" minOccurs="0"/>
+                <xsd:element ref="ns3:SharedWithUsers" minOccurs="0"/>
+                <xsd:element ref="ns3:SharedWithDetails" minOccurs="0"/>
+                <xsd:element ref="ns2:MediaServiceSearchProperties" minOccurs="0"/>
               </xsd:all>
             </xsd:complexType>
           </xsd:element>
@@ -11833,7 +11833,7 @@
       </xsd:complexType>
     </xsd:element>
   </xsd:schema>
-  <xsd:schema xmlns:xsd="http://www.w3.org/2001/XMLSchema" xmlns:xs="http://www.w3.org/2001/XMLSchema" xmlns:dms="http://schemas.microsoft.com/office/2006/documentManagement/types" xmlns:pc="http://schemas.microsoft.com/office/infopath/2007/PartnerControls" targetNamespace="80552416-44e0-4a04-af47-76b16d2fbd4a" elementFormDefault="qualified">
+  <xsd:schema xmlns:xsd="http://www.w3.org/2001/XMLSchema" xmlns:xs="http://www.w3.org/2001/XMLSchema" xmlns:dms="http://schemas.microsoft.com/office/2006/documentManagement/types" xmlns:pc="http://schemas.microsoft.com/office/infopath/2007/PartnerControls" targetNamespace="8574a8e8-5383-43f9-82c2-17454492c82a" elementFormDefault="qualified">
     <xsd:import namespace="http://schemas.microsoft.com/office/2006/documentManagement/types"/>
     <xsd:import namespace="http://schemas.microsoft.com/office/infopath/2007/PartnerControls"/>
     <xsd:element name="MediaServiceMetadata" ma:index="8" nillable="true" ma:displayName="MediaServiceMetadata" ma:hidden="true" ma:internalName="MediaServiceMetadata" ma:readOnly="true">
@@ -11846,65 +11846,55 @@
         <xsd:restriction base="dms:Note"/>
       </xsd:simpleType>
     </xsd:element>
-    <xsd:element name="MediaServiceSearchProperties" ma:index="10" nillable="true" ma:displayName="MediaServiceSearchProperties" ma:hidden="true" ma:internalName="MediaServiceSearchProperties" ma:readOnly="true">
-      <xsd:simpleType>
-        <xsd:restriction base="dms:Note"/>
-      </xsd:simpleType>
+    <xsd:element name="lcf76f155ced4ddcb4097134ff3c332f" ma:index="11" nillable="true" ma:taxonomy="true" ma:internalName="lcf76f155ced4ddcb4097134ff3c332f" ma:taxonomyFieldName="MediaServiceImageTags" ma:displayName="Etiquetas de imagen" ma:readOnly="false" ma:fieldId="{5cf76f15-5ced-4ddc-b409-7134ff3c332f}" ma:taxonomyMulti="true" ma:sspId="9ecfcf50-3ae4-46b1-98e5-a512559b6c25" ma:termSetId="09814cd3-568e-fe90-9814-8d621ff8fb84" ma:anchorId="fba54fb3-c3e1-fe81-a776-ca4b69148c4d" ma:open="true" ma:isKeyword="false">
+      <xsd:complexType>
+        <xsd:sequence>
+          <xsd:element ref="pc:Terms" minOccurs="0" maxOccurs="1"/>
+        </xsd:sequence>
+      </xsd:complexType>
     </xsd:element>
-    <xsd:element name="MediaServiceObjectDetectorVersions" ma:index="11" nillable="true" ma:displayName="MediaServiceObjectDetectorVersions" ma:hidden="true" ma:indexed="true" ma:internalName="MediaServiceObjectDetectorVersions" ma:readOnly="true">
-      <xsd:simpleType>
-        <xsd:restriction base="dms:Text"/>
-      </xsd:simpleType>
-    </xsd:element>
-    <xsd:element name="MediaServiceDateTaken" ma:index="12" nillable="true" ma:displayName="MediaServiceDateTaken" ma:hidden="true" ma:indexed="true" ma:internalName="MediaServiceDateTaken" ma:readOnly="true">
-      <xsd:simpleType>
-        <xsd:restriction base="dms:Text"/>
-      </xsd:simpleType>
-    </xsd:element>
-    <xsd:element name="MediaServiceGenerationTime" ma:index="13" nillable="true" ma:displayName="MediaServiceGenerationTime" ma:hidden="true" ma:internalName="MediaServiceGenerationTime" ma:readOnly="true">
-      <xsd:simpleType>
-        <xsd:restriction base="dms:Text"/>
-      </xsd:simpleType>
-    </xsd:element>
-    <xsd:element name="MediaServiceEventHashCode" ma:index="14" nillable="true" ma:displayName="MediaServiceEventHashCode" ma:hidden="true" ma:internalName="MediaServiceEventHashCode" ma:readOnly="true">
-      <xsd:simpleType>
-        <xsd:restriction base="dms:Text"/>
-      </xsd:simpleType>
-    </xsd:element>
-    <xsd:element name="MediaLengthInSeconds" ma:index="15" nillable="true" ma:displayName="MediaLengthInSeconds" ma:hidden="true" ma:internalName="MediaLengthInSeconds" ma:readOnly="true">
-      <xsd:simpleType>
-        <xsd:restriction base="dms:Unknown"/>
-      </xsd:simpleType>
-    </xsd:element>
-    <xsd:element name="MediaServiceOCR" ma:index="17" nillable="true" ma:displayName="Extracted Text" ma:internalName="MediaServiceOCR" ma:readOnly="true">
+    <xsd:element name="MediaServiceOCR" ma:index="13" nillable="true" ma:displayName="Extracted Text" ma:internalName="MediaServiceOCR" ma:readOnly="true">
       <xsd:simpleType>
         <xsd:restriction base="dms:Note">
           <xsd:maxLength value="255"/>
         </xsd:restriction>
       </xsd:simpleType>
     </xsd:element>
-    <xsd:element name="lcf76f155ced4ddcb4097134ff3c332f" ma:index="19" nillable="true" ma:taxonomy="true" ma:internalName="lcf76f155ced4ddcb4097134ff3c332f" ma:taxonomyFieldName="MediaServiceImageTags" ma:displayName="Etiquetas de imagen" ma:readOnly="false" ma:fieldId="{5cf76f15-5ced-4ddc-b409-7134ff3c332f}" ma:taxonomyMulti="true" ma:sspId="9ecfcf50-3ae4-46b1-98e5-a512559b6c25" ma:termSetId="09814cd3-568e-fe90-9814-8d621ff8fb84" ma:anchorId="fba54fb3-c3e1-fe81-a776-ca4b69148c4d" ma:open="true" ma:isKeyword="false">
-      <xsd:complexType>
-        <xsd:sequence>
-          <xsd:element ref="pc:Terms" minOccurs="0" maxOccurs="1"/>
-        </xsd:sequence>
-      </xsd:complexType>
-    </xsd:element>
-    <xsd:element name="MediaServiceLocation" ma:index="20" nillable="true" ma:displayName="Location" ma:indexed="true" ma:internalName="MediaServiceLocation" ma:readOnly="true">
+    <xsd:element name="MediaServiceGenerationTime" ma:index="14" nillable="true" ma:displayName="MediaServiceGenerationTime" ma:hidden="true" ma:internalName="MediaServiceGenerationTime" ma:readOnly="true">
       <xsd:simpleType>
         <xsd:restriction base="dms:Text"/>
       </xsd:simpleType>
     </xsd:element>
-    <xsd:element name="MediaServiceBillingMetadata" ma:index="21" nillable="true" ma:displayName="MediaServiceBillingMetadata" ma:hidden="true" ma:internalName="MediaServiceBillingMetadata" ma:readOnly="true">
+    <xsd:element name="MediaServiceEventHashCode" ma:index="15" nillable="true" ma:displayName="MediaServiceEventHashCode" ma:hidden="true" ma:internalName="MediaServiceEventHashCode" ma:readOnly="true">
+      <xsd:simpleType>
+        <xsd:restriction base="dms:Text"/>
+      </xsd:simpleType>
+    </xsd:element>
+    <xsd:element name="MediaServiceObjectDetectorVersions" ma:index="16" nillable="true" ma:displayName="MediaServiceObjectDetectorVersions" ma:hidden="true" ma:indexed="true" ma:internalName="MediaServiceObjectDetectorVersions" ma:readOnly="true">
+      <xsd:simpleType>
+        <xsd:restriction base="dms:Text"/>
+      </xsd:simpleType>
+    </xsd:element>
+    <xsd:element name="MediaLengthInSeconds" ma:index="17" nillable="true" ma:displayName="MediaLengthInSeconds" ma:hidden="true" ma:internalName="MediaLengthInSeconds" ma:readOnly="true">
+      <xsd:simpleType>
+        <xsd:restriction base="dms:Unknown"/>
+      </xsd:simpleType>
+    </xsd:element>
+    <xsd:element name="MediaServiceDateTaken" ma:index="18" nillable="true" ma:displayName="MediaServiceDateTaken" ma:hidden="true" ma:indexed="true" ma:internalName="MediaServiceDateTaken" ma:readOnly="true">
+      <xsd:simpleType>
+        <xsd:restriction base="dms:Text"/>
+      </xsd:simpleType>
+    </xsd:element>
+    <xsd:element name="MediaServiceSearchProperties" ma:index="21" nillable="true" ma:displayName="MediaServiceSearchProperties" ma:hidden="true" ma:internalName="MediaServiceSearchProperties" ma:readOnly="true">
       <xsd:simpleType>
         <xsd:restriction base="dms:Note"/>
       </xsd:simpleType>
     </xsd:element>
   </xsd:schema>
-  <xsd:schema xmlns:xsd="http://www.w3.org/2001/XMLSchema" xmlns:xs="http://www.w3.org/2001/XMLSchema" xmlns:dms="http://schemas.microsoft.com/office/2006/documentManagement/types" xmlns:pc="http://schemas.microsoft.com/office/infopath/2007/PartnerControls" targetNamespace="0b545d44-96d5-42ca-b29a-703cc1f24668" elementFormDefault="qualified">
+  <xsd:schema xmlns:xsd="http://www.w3.org/2001/XMLSchema" xmlns:xs="http://www.w3.org/2001/XMLSchema" xmlns:dms="http://schemas.microsoft.com/office/2006/documentManagement/types" xmlns:pc="http://schemas.microsoft.com/office/infopath/2007/PartnerControls" targetNamespace="d25c0998-d329-4608-bd73-3e8a880c0119" elementFormDefault="qualified">
     <xsd:import namespace="http://schemas.microsoft.com/office/2006/documentManagement/types"/>
     <xsd:import namespace="http://schemas.microsoft.com/office/infopath/2007/PartnerControls"/>
-    <xsd:element name="TaxCatchAll" ma:index="16" nillable="true" ma:displayName="Taxonomy Catch All Column" ma:hidden="true" ma:list="{71282893-daf6-47a9-a9d7-5a04190fa6f1}" ma:internalName="TaxCatchAll" ma:showField="CatchAllData" ma:web="0b545d44-96d5-42ca-b29a-703cc1f24668">
+    <xsd:element name="TaxCatchAll" ma:index="12" nillable="true" ma:displayName="Taxonomy Catch All Column" ma:hidden="true" ma:list="{674349b7-f6f9-4818-9607-755bdfad0d86}" ma:internalName="TaxCatchAll" ma:showField="CatchAllData" ma:web="d25c0998-d329-4608-bd73-3e8a880c0119">
       <xsd:complexType>
         <xsd:complexContent>
           <xsd:extension base="dms:MultiChoiceLookup">
@@ -11914,6 +11904,32 @@
           </xsd:extension>
         </xsd:complexContent>
       </xsd:complexType>
+    </xsd:element>
+    <xsd:element name="SharedWithUsers" ma:index="19" nillable="true" ma:displayName="Compartido con" ma:internalName="SharedWithUsers" ma:readOnly="true">
+      <xsd:complexType>
+        <xsd:complexContent>
+          <xsd:extension base="dms:UserMulti">
+            <xsd:sequence>
+              <xsd:element name="UserInfo" minOccurs="0" maxOccurs="unbounded">
+                <xsd:complexType>
+                  <xsd:sequence>
+                    <xsd:element name="DisplayName" type="xsd:string" minOccurs="0"/>
+                    <xsd:element name="AccountId" type="dms:UserId" minOccurs="0" nillable="true"/>
+                    <xsd:element name="AccountType" type="xsd:string" minOccurs="0"/>
+                  </xsd:sequence>
+                </xsd:complexType>
+              </xsd:element>
+            </xsd:sequence>
+          </xsd:extension>
+        </xsd:complexContent>
+      </xsd:complexType>
+    </xsd:element>
+    <xsd:element name="SharedWithDetails" ma:index="20" nillable="true" ma:displayName="Detalles de uso compartido" ma:internalName="SharedWithDetails" ma:readOnly="true">
+      <xsd:simpleType>
+        <xsd:restriction base="dms:Note">
+          <xsd:maxLength value="255"/>
+        </xsd:restriction>
+      </xsd:simpleType>
     </xsd:element>
   </xsd:schema>
   <xsd:schema xmlns="http://schemas.openxmlformats.org/package/2006/metadata/core-properties" xmlns:xsd="http://www.w3.org/2001/XMLSchema" xmlns:xsi="http://www.w3.org/2001/XMLSchema-instance" xmlns:dc="http://purl.org/dc/elements/1.1/" xmlns:dcterms="http://purl.org/dc/terms/" xmlns:odoc="http://schemas.microsoft.com/internal/obd" targetNamespace="http://schemas.openxmlformats.org/package/2006/metadata/core-properties" elementFormDefault="qualified" attributeFormDefault="unqualified" blockDefault="#all">
@@ -12018,10 +12034,10 @@
 <file path=customXml/item2.xml><?xml version="1.0" encoding="utf-8"?>
 <p:properties xmlns:p="http://schemas.microsoft.com/office/2006/metadata/properties" xmlns:xsi="http://www.w3.org/2001/XMLSchema-instance" xmlns:pc="http://schemas.microsoft.com/office/infopath/2007/PartnerControls">
   <documentManagement>
-    <lcf76f155ced4ddcb4097134ff3c332f xmlns="80552416-44e0-4a04-af47-76b16d2fbd4a">
+    <lcf76f155ced4ddcb4097134ff3c332f xmlns="8574a8e8-5383-43f9-82c2-17454492c82a">
       <Terms xmlns="http://schemas.microsoft.com/office/infopath/2007/PartnerControls"/>
     </lcf76f155ced4ddcb4097134ff3c332f>
-    <TaxCatchAll xmlns="0b545d44-96d5-42ca-b29a-703cc1f24668" xsi:nil="true"/>
+    <TaxCatchAll xmlns="d25c0998-d329-4608-bd73-3e8a880c0119" xsi:nil="true"/>
   </documentManagement>
 </p:properties>
 </file>
@@ -12036,22 +12052,7 @@
 </file>
 
 <file path=customXml/itemProps1.xml><?xml version="1.0" encoding="utf-8"?>
-<ds:datastoreItem xmlns:ds="http://schemas.openxmlformats.org/officeDocument/2006/customXml" ds:itemID="{959B4474-B18C-4EB2-A75E-9B4A0226A01F}">
-  <ds:schemaRefs>
-    <ds:schemaRef ds:uri="0b545d44-96d5-42ca-b29a-703cc1f24668"/>
-    <ds:schemaRef ds:uri="80552416-44e0-4a04-af47-76b16d2fbd4a"/>
-    <ds:schemaRef ds:uri="http://purl.org/dc/elements/1.1/"/>
-    <ds:schemaRef ds:uri="http://purl.org/dc/terms/"/>
-    <ds:schemaRef ds:uri="http://schemas.microsoft.com/internal/obd"/>
-    <ds:schemaRef ds:uri="http://schemas.microsoft.com/office/2006/documentManagement/types"/>
-    <ds:schemaRef ds:uri="http://schemas.microsoft.com/office/2006/metadata/contentType"/>
-    <ds:schemaRef ds:uri="http://schemas.microsoft.com/office/2006/metadata/properties"/>
-    <ds:schemaRef ds:uri="http://schemas.microsoft.com/office/2006/metadata/properties/metaAttributes"/>
-    <ds:schemaRef ds:uri="http://schemas.microsoft.com/office/infopath/2007/PartnerControls"/>
-    <ds:schemaRef ds:uri="http://schemas.openxmlformats.org/package/2006/metadata/core-properties"/>
-    <ds:schemaRef ds:uri="http://www.w3.org/2001/XMLSchema"/>
-  </ds:schemaRefs>
-</ds:datastoreItem>
+<ds:datastoreItem xmlns:ds="http://schemas.openxmlformats.org/officeDocument/2006/customXml" ds:itemID="{D525D849-BB8F-4434-AEA9-5ADB91C9FEB8}"/>
 </file>
 
 <file path=customXml/itemProps2.xml><?xml version="1.0" encoding="utf-8"?>

</xml_diff>